<commit_message>
Update deck cadence to every 3rd day
Rebuild the overview deck so the CI/CD slides match the schedule change
from weekly to every 3rd day.

Co-Authored-By: Claude Opus 4.8 <noreply@anthropic.com>
</commit_message>
<xml_diff>
--- a/docs/framework-deck.pptx
+++ b/docs/framework-deck.pptx
@@ -2348,7 +2348,7 @@
                 <a:ea typeface="Calibri" pitchFamily="34" charset="-122"/>
                 <a:cs typeface="Calibri" pitchFamily="34" charset="-120"/>
               </a:rPr>
-              <a:t>Every push and PR plus a weekly schedule; a failure pinpoints the leaking step instead of a vague “bookings are down”.</a:t>
+              <a:t>Every push and PR plus a scheduled run every 3rd day; a failure pinpoints the leaking step instead of a vague “bookings are down”.</a:t>
             </a:r>
             <a:endParaRPr lang="en-US" sz="1150" dirty="0"/>
           </a:p>
@@ -6015,7 +6015,7 @@
                 <a:ea typeface="Calibri" pitchFamily="34" charset="-122"/>
                 <a:cs typeface="Calibri" pitchFamily="34" charset="-120"/>
               </a:rPr>
-              <a:t>push · PR · weekly</a:t>
+              <a:t>push · PR · every</a:t>
             </a:r>
             <a:endParaRPr lang="en-US" sz="850" dirty="0"/>
           </a:p>
@@ -6032,7 +6032,7 @@
                 <a:ea typeface="Calibri" pitchFamily="34" charset="-122"/>
                 <a:cs typeface="Calibri" pitchFamily="34" charset="-120"/>
               </a:rPr>
-              <a:t>Mon 06:00 SAST</a:t>
+              <a:t>3rd day 06:00 SAST</a:t>
             </a:r>
             <a:endParaRPr lang="en-US" sz="850" dirty="0"/>
           </a:p>

</xml_diff>